<commit_message>
Adiciona pacote de marca pronto para uso e mockups do site e do app
- marca-pronta/: logotipo e símbolo em cor, negativo, preto e branco (SVG,
  PNG em vários tamanhos, PDF vetorial), ícones de app (iOS, Android, PWA),
  favicon.ico/svg, redes sociais, papelaria com sangria, arquivos para
  bordado, cores (.ase, .gpl, .css, .json), ícones de interface e padrão.
- Metades do sorriso como contornos fechados (sem clipPath), compatíveis
  com gráfica, bordado, vinil e editores.
- mockups/site: página em desktop (1440) e celular (390) com referência HTML.
- mockups/app: 10 telas do app do profissional e prancha de apresentação.

Co-Authored-By: Claude Opus 5.5 <noreply@anthropic.com>
Claude-Session: https://claude.ai/code/session_012zVDN11NobKyuBy8nJegSw
</commit_message>
<xml_diff>
--- a/tinindo-brand/apresentacao/Tinindo-apresentacao-socio.pptx
+++ b/tinindo-brand/apresentacao/Tinindo-apresentacao-socio.pptx
@@ -133,13 +133,13 @@
   <p:extLst>
     <p:ext uri="{521415D9-36F7-43E2-AB2F-B90AF26B5E84}">
       <p14:sectionLst xmlns:p14="http://schemas.microsoft.com/office/powerpoint/2010/main">
-        <p14:section name="Abertura" id="{25060fbb-5027-2e40-6c1d-1b20456b53c8}">
+        <p14:section name="Abertura" id="{cff603b6-a4fc-48e4-3a36-cc05da43d319}">
           <p14:sldIdLst>
             <p14:sldId id="256"/>
             <p14:sldId id="257"/>
           </p14:sldIdLst>
         </p14:section>
-        <p14:section name="Estratégia" id="{fa51cd0a-a327-f4e8-8aef-f96d2c039ebc}">
+        <p14:section name="Estratégia" id="{bd75b99f-1326-f5fa-cae2-b06f72e9a2d4}">
           <p14:sldIdLst>
             <p14:sldId id="258"/>
             <p14:sldId id="259"/>
@@ -148,13 +148,13 @@
             <p14:sldId id="262"/>
           </p14:sldIdLst>
         </p14:section>
-        <p14:section name="Caminho da identidade" id="{5ed3a7b2-4860-85f8-d173-6549063f13d2}">
+        <p14:section name="Caminho da identidade" id="{d7170b09-ac1b-4d4d-2484-d4e88887ac06}">
           <p14:sldIdLst>
             <p14:sldId id="263"/>
             <p14:sldId id="264"/>
           </p14:sldIdLst>
         </p14:section>
-        <p14:section name="Logotipo" id="{a038bdb3-45ba-8077-34fc-7c9d72fa48c3}">
+        <p14:section name="Logotipo" id="{acc4d8da-d2d4-2c02-6af6-9a75b2fec199}">
           <p14:sldIdLst>
             <p14:sldId id="265"/>
             <p14:sldId id="266"/>
@@ -163,7 +163,7 @@
             <p14:sldId id="272"/>
           </p14:sldIdLst>
         </p14:section>
-        <p14:section name="Cor, tipografia e produto" id="{5ddc7ae0-79b9-86d5-e26a-3f844bfd3d92}">
+        <p14:section name="Cor, tipografia e produto" id="{e4a7cefd-b4fd-4432-ad1b-3205194ac3d9}">
           <p14:sldIdLst>
             <p14:sldId id="268"/>
             <p14:sldId id="269"/>
@@ -173,7 +173,7 @@
             <p14:sldId id="275"/>
           </p14:sldIdLst>
         </p14:section>
-        <p14:section name="Aplicações, voz e próximos passos" id="{f2c54e13-8c69-a7e3-61e5-604eb00d8b21}">
+        <p14:section name="Aplicações, voz e próximos passos" id="{f302e51d-7cdf-ccb5-338f-eafe30b227a5}">
           <p14:sldIdLst>
             <p14:sldId id="276"/>
             <p14:sldId id="277"/>
@@ -14979,7 +14979,7 @@
                 <a:ea typeface="Arial" pitchFamily="34" charset="-122"/>
                 <a:cs typeface="Arial" pitchFamily="34" charset="-120"/>
               </a:rPr>
-              <a:t>Bordado e impressão precisam de prova; o corte ainda não está unido em contorno único.</a:t>
+              <a:t>Bordado e impressão precisam de prova. Os arquivos já são contornos fechados, prontos para produção.</a:t>
             </a:r>
             <a:endParaRPr lang="en-US" sz="1200" dirty="0"/>
           </a:p>
@@ -16335,7 +16335,7 @@
                 <a:ea typeface="Arial" pitchFamily="34" charset="-122"/>
                 <a:cs typeface="Arial" pitchFamily="34" charset="-120"/>
               </a:rPr>
-              <a:t>Unir o corte do sorriso em contorno único (editor vetorial)</a:t>
+              <a:t>Pedir provas de impressão e de bordado</a:t>
             </a:r>
             <a:endParaRPr lang="en-US" sz="1400" dirty="0"/>
           </a:p>
@@ -16399,7 +16399,7 @@
                 <a:ea typeface="Arial" pitchFamily="34" charset="-122"/>
                 <a:cs typeface="Arial" pitchFamily="34" charset="-120"/>
               </a:rPr>
-              <a:t>Pedir provas de impressão e de bordado</a:t>
+              <a:t>Testar o logotipo com 5 a 10 profissionais e contratantes (hipótese de amostra)</a:t>
             </a:r>
             <a:endParaRPr lang="en-US" sz="1400" dirty="0"/>
           </a:p>
@@ -16463,7 +16463,7 @@
                 <a:ea typeface="Arial" pitchFamily="34" charset="-122"/>
                 <a:cs typeface="Arial" pitchFamily="34" charset="-120"/>
               </a:rPr>
-              <a:t>Testar o logotipo com 5 a 10 profissionais e contratantes (hipótese de amostra)</a:t>
+              <a:t>Pesquisa de referências e de marcas com sorriso</a:t>
             </a:r>
             <a:endParaRPr lang="en-US" sz="1400" dirty="0"/>
           </a:p>
@@ -16527,7 +16527,7 @@
                 <a:ea typeface="Arial" pitchFamily="34" charset="-122"/>
                 <a:cs typeface="Arial" pitchFamily="34" charset="-120"/>
               </a:rPr>
-              <a:t>Pesquisa de referências e de marcas com sorriso</a:t>
+              <a:t>Auditoria de acessibilidade com teclado e leitor de tela</a:t>
             </a:r>
             <a:endParaRPr lang="en-US" sz="1400" dirty="0"/>
           </a:p>
@@ -16567,70 +16567,6 @@
         <p:spPr>
           <a:xfrm>
             <a:off x="6812280" y="4636008"/>
-            <a:ext cx="4663440" cy="548640"/>
-          </a:xfrm>
-          <a:prstGeom prst="rect">
-            <a:avLst/>
-          </a:prstGeom>
-          <a:noFill/>
-          <a:ln/>
-        </p:spPr>
-        <p:txBody>
-          <a:bodyPr wrap="square" lIns="0" tIns="0" rIns="0" bIns="0" rtlCol="0" anchor="ctr"/>
-          <a:lstStyle/>
-          <a:p>
-            <a:pPr indent="0" marL="0">
-              <a:buNone/>
-            </a:pPr>
-            <a:r>
-              <a:rPr lang="en-US" sz="1400" dirty="0">
-                <a:solidFill>
-                  <a:schemeClr val="tx1"/>
-                </a:solidFill>
-                <a:latin typeface="Arial" pitchFamily="34" charset="0"/>
-                <a:ea typeface="Arial" pitchFamily="34" charset="-122"/>
-                <a:cs typeface="Arial" pitchFamily="34" charset="-120"/>
-              </a:rPr>
-              <a:t>Auditoria de acessibilidade com teclado e leitor de tela</a:t>
-            </a:r>
-            <a:endParaRPr lang="en-US" sz="1400" dirty="0"/>
-          </a:p>
-        </p:txBody>
-      </p:sp>
-      <p:sp>
-        <p:nvSpPr>
-          <p:cNvPr id="32" name="ponto"/>
-          <p:cNvSpPr/>
-          <p:nvPr/>
-        </p:nvSpPr>
-        <p:spPr>
-          <a:xfrm>
-            <a:off x="6492240" y="5394960"/>
-            <a:ext cx="164592" cy="164592"/>
-          </a:xfrm>
-          <a:prstGeom prst="ellipse">
-            <a:avLst/>
-          </a:prstGeom>
-          <a:solidFill>
-            <a:schemeClr val="accent1"/>
-          </a:solidFill>
-          <a:ln w="12700">
-            <a:solidFill>
-              <a:schemeClr val="accent1"/>
-            </a:solidFill>
-            <a:prstDash val="solid"/>
-          </a:ln>
-        </p:spPr>
-      </p:sp>
-      <p:sp>
-        <p:nvSpPr>
-          <p:cNvPr id="33" name="Text 31"/>
-          <p:cNvSpPr txBox="1"/>
-          <p:nvPr/>
-        </p:nvSpPr>
-        <p:spPr>
-          <a:xfrm>
-            <a:off x="6812280" y="5257800"/>
             <a:ext cx="4663440" cy="548640"/>
           </a:xfrm>
           <a:prstGeom prst="rect">

</xml_diff>